<commit_message>
Enhance PowerPoint design to match website style
</commit_message>
<xml_diff>
--- a/AI_Traffic_Presentation_Premium.pptx
+++ b/AI_Traffic_Presentation_Premium.pptx
@@ -3114,7 +3114,7 @@
         <p:spPr>
           <a:xfrm>
             <a:off x="0" y="0"/>
-            <a:ext cx="12188952" cy="91440"/>
+            <a:ext cx="274320" cy="6858000"/>
           </a:xfrm>
           <a:prstGeom prst="rect">
             <a:avLst/>
@@ -3156,8 +3156,8 @@
         </p:nvSpPr>
         <p:spPr>
           <a:xfrm>
-            <a:off x="457200" y="1828800"/>
-            <a:ext cx="10972800" cy="1828800"/>
+            <a:off x="731520" y="1828800"/>
+            <a:ext cx="10058400" cy="2286000"/>
           </a:xfrm>
           <a:prstGeom prst="rect">
             <a:avLst/>
@@ -3165,13 +3165,13 @@
           <a:noFill/>
         </p:spPr>
         <p:txBody>
-          <a:bodyPr wrap="none">
+          <a:bodyPr wrap="square">
             <a:spAutoFit/>
           </a:bodyPr>
           <a:lstStyle/>
           <a:p>
             <a:pPr algn="l">
-              <a:defRPr b="1" sz="4400">
+              <a:defRPr b="1" sz="4600">
                 <a:solidFill>
                   <a:srgbClr val="0F172A"/>
                 </a:solidFill>
@@ -3191,8 +3191,8 @@
         </p:nvSpPr>
         <p:spPr>
           <a:xfrm>
-            <a:off x="457200" y="3657600"/>
-            <a:ext cx="10972800" cy="914400"/>
+            <a:off x="731520" y="4389120"/>
+            <a:ext cx="10058400" cy="1371600"/>
           </a:xfrm>
           <a:prstGeom prst="rect">
             <a:avLst/>
@@ -3205,7 +3205,7 @@
           </a:bodyPr>
           <a:lstStyle/>
           <a:p>
-            <a:pPr algn="l">
+            <a:pPr>
               <a:defRPr sz="2400">
                 <a:solidFill>
                   <a:srgbClr val="475569"/>
@@ -3215,10 +3215,89 @@
             <a:r>
               <a:t>Студент: Сулейменов Алишер</a:t>
             </a:r>
-          </a:p>
-          <a:p>
+            <a:br/>
             <a:r>
               <a:t>Ғылыми жетекші: Кусаинова Айнур</a:t>
+            </a:r>
+          </a:p>
+        </p:txBody>
+      </p:sp>
+      <p:sp>
+        <p:nvSpPr>
+          <p:cNvPr id="5" name="Rectangle 4"/>
+          <p:cNvSpPr/>
+          <p:nvPr/>
+        </p:nvSpPr>
+        <p:spPr>
+          <a:xfrm>
+            <a:off x="731520" y="731520"/>
+            <a:ext cx="3657600" cy="457200"/>
+          </a:xfrm>
+          <a:prstGeom prst="rect">
+            <a:avLst/>
+          </a:prstGeom>
+          <a:solidFill>
+            <a:srgbClr val="EFF6FF"/>
+          </a:solidFill>
+          <a:ln>
+            <a:solidFill>
+              <a:srgbClr val="BFDBFE"/>
+            </a:solidFill>
+          </a:ln>
+        </p:spPr>
+        <p:style>
+          <a:lnRef idx="1">
+            <a:schemeClr val="accent1"/>
+          </a:lnRef>
+          <a:fillRef idx="3">
+            <a:schemeClr val="accent1"/>
+          </a:fillRef>
+          <a:effectRef idx="2">
+            <a:schemeClr val="accent1"/>
+          </a:effectRef>
+          <a:fontRef idx="minor">
+            <a:schemeClr val="lt1"/>
+          </a:fontRef>
+        </p:style>
+        <p:txBody>
+          <a:bodyPr rtlCol="0" anchor="ctr"/>
+          <a:lstStyle/>
+          <a:p>
+            <a:pPr algn="ctr"/>
+          </a:p>
+        </p:txBody>
+      </p:sp>
+      <p:sp>
+        <p:nvSpPr>
+          <p:cNvPr id="6" name="TextBox 5"/>
+          <p:cNvSpPr txBox="1"/>
+          <p:nvPr/>
+        </p:nvSpPr>
+        <p:spPr>
+          <a:xfrm>
+            <a:off x="914400" y="777240"/>
+            <a:ext cx="3474720" cy="365760"/>
+          </a:xfrm>
+          <a:prstGeom prst="rect">
+            <a:avLst/>
+          </a:prstGeom>
+          <a:noFill/>
+        </p:spPr>
+        <p:txBody>
+          <a:bodyPr wrap="none">
+            <a:spAutoFit/>
+          </a:bodyPr>
+          <a:lstStyle/>
+          <a:p>
+            <a:pPr>
+              <a:defRPr sz="1200" b="1">
+                <a:solidFill>
+                  <a:srgbClr val="2563EB"/>
+                </a:solidFill>
+              </a:defRPr>
+            </a:pPr>
+            <a:r>
+              <a:t>AI TRAFFIC PROJECT | 2026</a:t>
             </a:r>
           </a:p>
         </p:txBody>
@@ -3237,7 +3316,7 @@
     <p:bg>
       <p:bgPr>
         <a:solidFill>
-          <a:srgbClr val="FFFFFF"/>
+          <a:srgbClr val="F1F5F9"/>
         </a:solidFill>
         <a:effectLst/>
       </p:bgPr>
@@ -3251,36 +3330,46 @@
       <p:grpSpPr/>
       <p:sp>
         <p:nvSpPr>
-          <p:cNvPr id="2" name="TextBox 1"/>
-          <p:cNvSpPr txBox="1"/>
+          <p:cNvPr id="2" name="Rectangle 1"/>
+          <p:cNvSpPr/>
           <p:nvPr/>
         </p:nvSpPr>
         <p:spPr>
           <a:xfrm>
-            <a:off x="457200" y="457200"/>
-            <a:ext cx="10972800" cy="914400"/>
+            <a:off x="365760" y="365760"/>
+            <a:ext cx="11430000" cy="6126480"/>
           </a:xfrm>
           <a:prstGeom prst="rect">
             <a:avLst/>
           </a:prstGeom>
-          <a:noFill/>
-        </p:spPr>
-        <p:txBody>
-          <a:bodyPr wrap="none">
-            <a:spAutoFit/>
-          </a:bodyPr>
-          <a:lstStyle/>
-          <a:p>
-            <a:pPr>
-              <a:defRPr b="1" sz="3600">
-                <a:solidFill>
-                  <a:srgbClr val="0F172A"/>
-                </a:solidFill>
-              </a:defRPr>
-            </a:pPr>
-            <a:r>
-              <a:t>9. Қорытынды</a:t>
-            </a:r>
+          <a:solidFill>
+            <a:srgbClr val="FFFFFF"/>
+          </a:solidFill>
+          <a:ln w="12700">
+            <a:solidFill>
+              <a:srgbClr val="E2E8F0"/>
+            </a:solidFill>
+          </a:ln>
+        </p:spPr>
+        <p:style>
+          <a:lnRef idx="1">
+            <a:schemeClr val="accent1"/>
+          </a:lnRef>
+          <a:fillRef idx="3">
+            <a:schemeClr val="accent1"/>
+          </a:fillRef>
+          <a:effectRef idx="2">
+            <a:schemeClr val="accent1"/>
+          </a:effectRef>
+          <a:fontRef idx="minor">
+            <a:schemeClr val="lt1"/>
+          </a:fontRef>
+        </p:style>
+        <p:txBody>
+          <a:bodyPr rtlCol="0" anchor="ctr"/>
+          <a:lstStyle/>
+          <a:p>
+            <a:pPr algn="ctr"/>
           </a:p>
         </p:txBody>
       </p:sp>
@@ -3292,8 +3381,8 @@
         </p:nvSpPr>
         <p:spPr>
           <a:xfrm>
-            <a:off x="457200" y="1188720"/>
-            <a:ext cx="1371600" cy="45720"/>
+            <a:off x="365760" y="365760"/>
+            <a:ext cx="11430000" cy="137160"/>
           </a:xfrm>
           <a:prstGeom prst="rect">
             <a:avLst/>
@@ -3335,8 +3424,8 @@
         </p:nvSpPr>
         <p:spPr>
           <a:xfrm>
-            <a:off x="457200" y="1645920"/>
-            <a:ext cx="10972800" cy="4572000"/>
+            <a:off x="731520" y="731520"/>
+            <a:ext cx="10058400" cy="914400"/>
           </a:xfrm>
           <a:prstGeom prst="rect">
             <a:avLst/>
@@ -3344,6 +3433,84 @@
           <a:noFill/>
         </p:spPr>
         <p:txBody>
+          <a:bodyPr wrap="none">
+            <a:spAutoFit/>
+          </a:bodyPr>
+          <a:lstStyle/>
+          <a:p>
+            <a:pPr>
+              <a:defRPr b="1" sz="3200">
+                <a:solidFill>
+                  <a:srgbClr val="0F172A"/>
+                </a:solidFill>
+              </a:defRPr>
+            </a:pPr>
+            <a:r>
+              <a:t>9. Қорытынды</a:t>
+            </a:r>
+          </a:p>
+        </p:txBody>
+      </p:sp>
+      <p:sp>
+        <p:nvSpPr>
+          <p:cNvPr id="5" name="Rectangle 4"/>
+          <p:cNvSpPr/>
+          <p:nvPr/>
+        </p:nvSpPr>
+        <p:spPr>
+          <a:xfrm>
+            <a:off x="731520" y="1463040"/>
+            <a:ext cx="1371600" cy="36576"/>
+          </a:xfrm>
+          <a:prstGeom prst="rect">
+            <a:avLst/>
+          </a:prstGeom>
+          <a:solidFill>
+            <a:srgbClr val="2563EB"/>
+          </a:solidFill>
+          <a:ln>
+            <a:noFill/>
+          </a:ln>
+        </p:spPr>
+        <p:style>
+          <a:lnRef idx="1">
+            <a:schemeClr val="accent1"/>
+          </a:lnRef>
+          <a:fillRef idx="3">
+            <a:schemeClr val="accent1"/>
+          </a:fillRef>
+          <a:effectRef idx="2">
+            <a:schemeClr val="accent1"/>
+          </a:effectRef>
+          <a:fontRef idx="minor">
+            <a:schemeClr val="lt1"/>
+          </a:fontRef>
+        </p:style>
+        <p:txBody>
+          <a:bodyPr rtlCol="0" anchor="ctr"/>
+          <a:lstStyle/>
+          <a:p>
+            <a:pPr algn="ctr"/>
+          </a:p>
+        </p:txBody>
+      </p:sp>
+      <p:sp>
+        <p:nvSpPr>
+          <p:cNvPr id="6" name="TextBox 5"/>
+          <p:cNvSpPr txBox="1"/>
+          <p:nvPr/>
+        </p:nvSpPr>
+        <p:spPr>
+          <a:xfrm>
+            <a:off x="914400" y="2011680"/>
+            <a:ext cx="10058400" cy="4114800"/>
+          </a:xfrm>
+          <a:prstGeom prst="rect">
+            <a:avLst/>
+          </a:prstGeom>
+          <a:noFill/>
+        </p:spPr>
+        <p:txBody>
           <a:bodyPr wrap="square">
             <a:spAutoFit/>
           </a:bodyPr>
@@ -3352,9 +3519,9 @@
           <a:p>
             <a:pPr>
               <a:spcAft>
-                <a:spcPts val="1200"/>
+                <a:spcPts val="1500"/>
               </a:spcAft>
-              <a:defRPr sz="2000">
+              <a:defRPr sz="2200">
                 <a:solidFill>
                   <a:srgbClr val="334155"/>
                 </a:solidFill>
@@ -3367,9 +3534,9 @@
           <a:p>
             <a:pPr>
               <a:spcAft>
-                <a:spcPts val="1200"/>
+                <a:spcPts val="1500"/>
               </a:spcAft>
-              <a:defRPr sz="2000">
+              <a:defRPr sz="2200">
                 <a:solidFill>
                   <a:srgbClr val="334155"/>
                 </a:solidFill>
@@ -3382,9 +3549,9 @@
           <a:p>
             <a:pPr>
               <a:spcAft>
-                <a:spcPts val="1200"/>
+                <a:spcPts val="1500"/>
               </a:spcAft>
-              <a:defRPr sz="2000">
+              <a:defRPr sz="2200">
                 <a:solidFill>
                   <a:srgbClr val="334155"/>
                 </a:solidFill>
@@ -3397,9 +3564,9 @@
           <a:p>
             <a:pPr>
               <a:spcAft>
-                <a:spcPts val="1200"/>
+                <a:spcPts val="1500"/>
               </a:spcAft>
-              <a:defRPr sz="2000">
+              <a:defRPr sz="2200">
                 <a:solidFill>
                   <a:srgbClr val="334155"/>
                 </a:solidFill>
@@ -3425,7 +3592,7 @@
     <p:bg>
       <p:bgPr>
         <a:solidFill>
-          <a:srgbClr val="FFFFFF"/>
+          <a:srgbClr val="F1F5F9"/>
         </a:solidFill>
         <a:effectLst/>
       </p:bgPr>
@@ -3439,36 +3606,46 @@
       <p:grpSpPr/>
       <p:sp>
         <p:nvSpPr>
-          <p:cNvPr id="2" name="TextBox 1"/>
-          <p:cNvSpPr txBox="1"/>
+          <p:cNvPr id="2" name="Rectangle 1"/>
+          <p:cNvSpPr/>
           <p:nvPr/>
         </p:nvSpPr>
         <p:spPr>
           <a:xfrm>
-            <a:off x="457200" y="457200"/>
-            <a:ext cx="10972800" cy="914400"/>
+            <a:off x="365760" y="365760"/>
+            <a:ext cx="11430000" cy="6126480"/>
           </a:xfrm>
           <a:prstGeom prst="rect">
             <a:avLst/>
           </a:prstGeom>
-          <a:noFill/>
-        </p:spPr>
-        <p:txBody>
-          <a:bodyPr wrap="none">
-            <a:spAutoFit/>
-          </a:bodyPr>
-          <a:lstStyle/>
-          <a:p>
-            <a:pPr>
-              <a:defRPr b="1" sz="3600">
-                <a:solidFill>
-                  <a:srgbClr val="0F172A"/>
-                </a:solidFill>
-              </a:defRPr>
-            </a:pPr>
-            <a:r>
-              <a:t>1. Тақырыптың өзектілігі</a:t>
-            </a:r>
+          <a:solidFill>
+            <a:srgbClr val="FFFFFF"/>
+          </a:solidFill>
+          <a:ln w="12700">
+            <a:solidFill>
+              <a:srgbClr val="E2E8F0"/>
+            </a:solidFill>
+          </a:ln>
+        </p:spPr>
+        <p:style>
+          <a:lnRef idx="1">
+            <a:schemeClr val="accent1"/>
+          </a:lnRef>
+          <a:fillRef idx="3">
+            <a:schemeClr val="accent1"/>
+          </a:fillRef>
+          <a:effectRef idx="2">
+            <a:schemeClr val="accent1"/>
+          </a:effectRef>
+          <a:fontRef idx="minor">
+            <a:schemeClr val="lt1"/>
+          </a:fontRef>
+        </p:style>
+        <p:txBody>
+          <a:bodyPr rtlCol="0" anchor="ctr"/>
+          <a:lstStyle/>
+          <a:p>
+            <a:pPr algn="ctr"/>
           </a:p>
         </p:txBody>
       </p:sp>
@@ -3480,8 +3657,8 @@
         </p:nvSpPr>
         <p:spPr>
           <a:xfrm>
-            <a:off x="457200" y="1188720"/>
-            <a:ext cx="1371600" cy="45720"/>
+            <a:off x="365760" y="365760"/>
+            <a:ext cx="11430000" cy="137160"/>
           </a:xfrm>
           <a:prstGeom prst="rect">
             <a:avLst/>
@@ -3523,8 +3700,8 @@
         </p:nvSpPr>
         <p:spPr>
           <a:xfrm>
-            <a:off x="457200" y="1645920"/>
-            <a:ext cx="10972800" cy="4572000"/>
+            <a:off x="731520" y="731520"/>
+            <a:ext cx="10058400" cy="914400"/>
           </a:xfrm>
           <a:prstGeom prst="rect">
             <a:avLst/>
@@ -3532,6 +3709,84 @@
           <a:noFill/>
         </p:spPr>
         <p:txBody>
+          <a:bodyPr wrap="none">
+            <a:spAutoFit/>
+          </a:bodyPr>
+          <a:lstStyle/>
+          <a:p>
+            <a:pPr>
+              <a:defRPr b="1" sz="3200">
+                <a:solidFill>
+                  <a:srgbClr val="0F172A"/>
+                </a:solidFill>
+              </a:defRPr>
+            </a:pPr>
+            <a:r>
+              <a:t>1. Тақырыптың өзектілігі</a:t>
+            </a:r>
+          </a:p>
+        </p:txBody>
+      </p:sp>
+      <p:sp>
+        <p:nvSpPr>
+          <p:cNvPr id="5" name="Rectangle 4"/>
+          <p:cNvSpPr/>
+          <p:nvPr/>
+        </p:nvSpPr>
+        <p:spPr>
+          <a:xfrm>
+            <a:off x="731520" y="1463040"/>
+            <a:ext cx="1371600" cy="36576"/>
+          </a:xfrm>
+          <a:prstGeom prst="rect">
+            <a:avLst/>
+          </a:prstGeom>
+          <a:solidFill>
+            <a:srgbClr val="2563EB"/>
+          </a:solidFill>
+          <a:ln>
+            <a:noFill/>
+          </a:ln>
+        </p:spPr>
+        <p:style>
+          <a:lnRef idx="1">
+            <a:schemeClr val="accent1"/>
+          </a:lnRef>
+          <a:fillRef idx="3">
+            <a:schemeClr val="accent1"/>
+          </a:fillRef>
+          <a:effectRef idx="2">
+            <a:schemeClr val="accent1"/>
+          </a:effectRef>
+          <a:fontRef idx="minor">
+            <a:schemeClr val="lt1"/>
+          </a:fontRef>
+        </p:style>
+        <p:txBody>
+          <a:bodyPr rtlCol="0" anchor="ctr"/>
+          <a:lstStyle/>
+          <a:p>
+            <a:pPr algn="ctr"/>
+          </a:p>
+        </p:txBody>
+      </p:sp>
+      <p:sp>
+        <p:nvSpPr>
+          <p:cNvPr id="6" name="TextBox 5"/>
+          <p:cNvSpPr txBox="1"/>
+          <p:nvPr/>
+        </p:nvSpPr>
+        <p:spPr>
+          <a:xfrm>
+            <a:off x="914400" y="2011680"/>
+            <a:ext cx="10058400" cy="4114800"/>
+          </a:xfrm>
+          <a:prstGeom prst="rect">
+            <a:avLst/>
+          </a:prstGeom>
+          <a:noFill/>
+        </p:spPr>
+        <p:txBody>
           <a:bodyPr wrap="square">
             <a:spAutoFit/>
           </a:bodyPr>
@@ -3540,9 +3795,9 @@
           <a:p>
             <a:pPr>
               <a:spcAft>
-                <a:spcPts val="1200"/>
+                <a:spcPts val="1500"/>
               </a:spcAft>
-              <a:defRPr sz="2000">
+              <a:defRPr sz="2200">
                 <a:solidFill>
                   <a:srgbClr val="334155"/>
                 </a:solidFill>
@@ -3555,9 +3810,9 @@
           <a:p>
             <a:pPr>
               <a:spcAft>
-                <a:spcPts val="1200"/>
+                <a:spcPts val="1500"/>
               </a:spcAft>
-              <a:defRPr sz="2000">
+              <a:defRPr sz="2200">
                 <a:solidFill>
                   <a:srgbClr val="334155"/>
                 </a:solidFill>
@@ -3570,9 +3825,9 @@
           <a:p>
             <a:pPr>
               <a:spcAft>
-                <a:spcPts val="1200"/>
+                <a:spcPts val="1500"/>
               </a:spcAft>
-              <a:defRPr sz="2000">
+              <a:defRPr sz="2200">
                 <a:solidFill>
                   <a:srgbClr val="334155"/>
                 </a:solidFill>
@@ -3585,9 +3840,9 @@
           <a:p>
             <a:pPr>
               <a:spcAft>
-                <a:spcPts val="1200"/>
+                <a:spcPts val="1500"/>
               </a:spcAft>
-              <a:defRPr sz="2000">
+              <a:defRPr sz="2200">
                 <a:solidFill>
                   <a:srgbClr val="334155"/>
                 </a:solidFill>
@@ -3613,7 +3868,7 @@
     <p:bg>
       <p:bgPr>
         <a:solidFill>
-          <a:srgbClr val="FFFFFF"/>
+          <a:srgbClr val="F1F5F9"/>
         </a:solidFill>
         <a:effectLst/>
       </p:bgPr>
@@ -3627,36 +3882,46 @@
       <p:grpSpPr/>
       <p:sp>
         <p:nvSpPr>
-          <p:cNvPr id="2" name="TextBox 1"/>
-          <p:cNvSpPr txBox="1"/>
+          <p:cNvPr id="2" name="Rectangle 1"/>
+          <p:cNvSpPr/>
           <p:nvPr/>
         </p:nvSpPr>
         <p:spPr>
           <a:xfrm>
-            <a:off x="457200" y="457200"/>
-            <a:ext cx="10972800" cy="914400"/>
+            <a:off x="365760" y="365760"/>
+            <a:ext cx="11430000" cy="6126480"/>
           </a:xfrm>
           <a:prstGeom prst="rect">
             <a:avLst/>
           </a:prstGeom>
-          <a:noFill/>
-        </p:spPr>
-        <p:txBody>
-          <a:bodyPr wrap="none">
-            <a:spAutoFit/>
-          </a:bodyPr>
-          <a:lstStyle/>
-          <a:p>
-            <a:pPr>
-              <a:defRPr b="1" sz="3600">
-                <a:solidFill>
-                  <a:srgbClr val="0F172A"/>
-                </a:solidFill>
-              </a:defRPr>
-            </a:pPr>
-            <a:r>
-              <a:t>2. Жұмыс мақсаты</a:t>
-            </a:r>
+          <a:solidFill>
+            <a:srgbClr val="FFFFFF"/>
+          </a:solidFill>
+          <a:ln w="12700">
+            <a:solidFill>
+              <a:srgbClr val="E2E8F0"/>
+            </a:solidFill>
+          </a:ln>
+        </p:spPr>
+        <p:style>
+          <a:lnRef idx="1">
+            <a:schemeClr val="accent1"/>
+          </a:lnRef>
+          <a:fillRef idx="3">
+            <a:schemeClr val="accent1"/>
+          </a:fillRef>
+          <a:effectRef idx="2">
+            <a:schemeClr val="accent1"/>
+          </a:effectRef>
+          <a:fontRef idx="minor">
+            <a:schemeClr val="lt1"/>
+          </a:fontRef>
+        </p:style>
+        <p:txBody>
+          <a:bodyPr rtlCol="0" anchor="ctr"/>
+          <a:lstStyle/>
+          <a:p>
+            <a:pPr algn="ctr"/>
           </a:p>
         </p:txBody>
       </p:sp>
@@ -3668,8 +3933,8 @@
         </p:nvSpPr>
         <p:spPr>
           <a:xfrm>
-            <a:off x="457200" y="1188720"/>
-            <a:ext cx="1371600" cy="45720"/>
+            <a:off x="365760" y="365760"/>
+            <a:ext cx="11430000" cy="137160"/>
           </a:xfrm>
           <a:prstGeom prst="rect">
             <a:avLst/>
@@ -3711,8 +3976,8 @@
         </p:nvSpPr>
         <p:spPr>
           <a:xfrm>
-            <a:off x="457200" y="1645920"/>
-            <a:ext cx="10972800" cy="4572000"/>
+            <a:off x="731520" y="731520"/>
+            <a:ext cx="10058400" cy="914400"/>
           </a:xfrm>
           <a:prstGeom prst="rect">
             <a:avLst/>
@@ -3720,6 +3985,84 @@
           <a:noFill/>
         </p:spPr>
         <p:txBody>
+          <a:bodyPr wrap="none">
+            <a:spAutoFit/>
+          </a:bodyPr>
+          <a:lstStyle/>
+          <a:p>
+            <a:pPr>
+              <a:defRPr b="1" sz="3200">
+                <a:solidFill>
+                  <a:srgbClr val="0F172A"/>
+                </a:solidFill>
+              </a:defRPr>
+            </a:pPr>
+            <a:r>
+              <a:t>2. Жұмыс мақсаты</a:t>
+            </a:r>
+          </a:p>
+        </p:txBody>
+      </p:sp>
+      <p:sp>
+        <p:nvSpPr>
+          <p:cNvPr id="5" name="Rectangle 4"/>
+          <p:cNvSpPr/>
+          <p:nvPr/>
+        </p:nvSpPr>
+        <p:spPr>
+          <a:xfrm>
+            <a:off x="731520" y="1463040"/>
+            <a:ext cx="1371600" cy="36576"/>
+          </a:xfrm>
+          <a:prstGeom prst="rect">
+            <a:avLst/>
+          </a:prstGeom>
+          <a:solidFill>
+            <a:srgbClr val="2563EB"/>
+          </a:solidFill>
+          <a:ln>
+            <a:noFill/>
+          </a:ln>
+        </p:spPr>
+        <p:style>
+          <a:lnRef idx="1">
+            <a:schemeClr val="accent1"/>
+          </a:lnRef>
+          <a:fillRef idx="3">
+            <a:schemeClr val="accent1"/>
+          </a:fillRef>
+          <a:effectRef idx="2">
+            <a:schemeClr val="accent1"/>
+          </a:effectRef>
+          <a:fontRef idx="minor">
+            <a:schemeClr val="lt1"/>
+          </a:fontRef>
+        </p:style>
+        <p:txBody>
+          <a:bodyPr rtlCol="0" anchor="ctr"/>
+          <a:lstStyle/>
+          <a:p>
+            <a:pPr algn="ctr"/>
+          </a:p>
+        </p:txBody>
+      </p:sp>
+      <p:sp>
+        <p:nvSpPr>
+          <p:cNvPr id="6" name="TextBox 5"/>
+          <p:cNvSpPr txBox="1"/>
+          <p:nvPr/>
+        </p:nvSpPr>
+        <p:spPr>
+          <a:xfrm>
+            <a:off x="914400" y="2011680"/>
+            <a:ext cx="10058400" cy="4114800"/>
+          </a:xfrm>
+          <a:prstGeom prst="rect">
+            <a:avLst/>
+          </a:prstGeom>
+          <a:noFill/>
+        </p:spPr>
+        <p:txBody>
           <a:bodyPr wrap="square">
             <a:spAutoFit/>
           </a:bodyPr>
@@ -3728,9 +4071,9 @@
           <a:p>
             <a:pPr>
               <a:spcAft>
-                <a:spcPts val="1200"/>
+                <a:spcPts val="1500"/>
               </a:spcAft>
-              <a:defRPr sz="2000">
+              <a:defRPr sz="2200">
                 <a:solidFill>
                   <a:srgbClr val="334155"/>
                 </a:solidFill>
@@ -3743,9 +4086,9 @@
           <a:p>
             <a:pPr>
               <a:spcAft>
-                <a:spcPts val="1200"/>
+                <a:spcPts val="1500"/>
               </a:spcAft>
-              <a:defRPr sz="2000">
+              <a:defRPr sz="2200">
                 <a:solidFill>
                   <a:srgbClr val="334155"/>
                 </a:solidFill>
@@ -3758,9 +4101,9 @@
           <a:p>
             <a:pPr>
               <a:spcAft>
-                <a:spcPts val="1200"/>
+                <a:spcPts val="1500"/>
               </a:spcAft>
-              <a:defRPr sz="2000">
+              <a:defRPr sz="2200">
                 <a:solidFill>
                   <a:srgbClr val="334155"/>
                 </a:solidFill>
@@ -3773,9 +4116,9 @@
           <a:p>
             <a:pPr>
               <a:spcAft>
-                <a:spcPts val="1200"/>
+                <a:spcPts val="1500"/>
               </a:spcAft>
-              <a:defRPr sz="2000">
+              <a:defRPr sz="2200">
                 <a:solidFill>
                   <a:srgbClr val="334155"/>
                 </a:solidFill>
@@ -3801,7 +4144,7 @@
     <p:bg>
       <p:bgPr>
         <a:solidFill>
-          <a:srgbClr val="FFFFFF"/>
+          <a:srgbClr val="F1F5F9"/>
         </a:solidFill>
         <a:effectLst/>
       </p:bgPr>
@@ -3815,36 +4158,46 @@
       <p:grpSpPr/>
       <p:sp>
         <p:nvSpPr>
-          <p:cNvPr id="2" name="TextBox 1"/>
-          <p:cNvSpPr txBox="1"/>
+          <p:cNvPr id="2" name="Rectangle 1"/>
+          <p:cNvSpPr/>
           <p:nvPr/>
         </p:nvSpPr>
         <p:spPr>
           <a:xfrm>
-            <a:off x="457200" y="457200"/>
-            <a:ext cx="10972800" cy="914400"/>
+            <a:off x="365760" y="365760"/>
+            <a:ext cx="11430000" cy="6126480"/>
           </a:xfrm>
           <a:prstGeom prst="rect">
             <a:avLst/>
           </a:prstGeom>
-          <a:noFill/>
-        </p:spPr>
-        <p:txBody>
-          <a:bodyPr wrap="none">
-            <a:spAutoFit/>
-          </a:bodyPr>
-          <a:lstStyle/>
-          <a:p>
-            <a:pPr>
-              <a:defRPr b="1" sz="3600">
-                <a:solidFill>
-                  <a:srgbClr val="0F172A"/>
-                </a:solidFill>
-              </a:defRPr>
-            </a:pPr>
-            <a:r>
-              <a:t>3. Зерттеу міндеттері</a:t>
-            </a:r>
+          <a:solidFill>
+            <a:srgbClr val="FFFFFF"/>
+          </a:solidFill>
+          <a:ln w="12700">
+            <a:solidFill>
+              <a:srgbClr val="E2E8F0"/>
+            </a:solidFill>
+          </a:ln>
+        </p:spPr>
+        <p:style>
+          <a:lnRef idx="1">
+            <a:schemeClr val="accent1"/>
+          </a:lnRef>
+          <a:fillRef idx="3">
+            <a:schemeClr val="accent1"/>
+          </a:fillRef>
+          <a:effectRef idx="2">
+            <a:schemeClr val="accent1"/>
+          </a:effectRef>
+          <a:fontRef idx="minor">
+            <a:schemeClr val="lt1"/>
+          </a:fontRef>
+        </p:style>
+        <p:txBody>
+          <a:bodyPr rtlCol="0" anchor="ctr"/>
+          <a:lstStyle/>
+          <a:p>
+            <a:pPr algn="ctr"/>
           </a:p>
         </p:txBody>
       </p:sp>
@@ -3856,8 +4209,8 @@
         </p:nvSpPr>
         <p:spPr>
           <a:xfrm>
-            <a:off x="457200" y="1188720"/>
-            <a:ext cx="1371600" cy="45720"/>
+            <a:off x="365760" y="365760"/>
+            <a:ext cx="11430000" cy="137160"/>
           </a:xfrm>
           <a:prstGeom prst="rect">
             <a:avLst/>
@@ -3899,8 +4252,8 @@
         </p:nvSpPr>
         <p:spPr>
           <a:xfrm>
-            <a:off x="457200" y="1645920"/>
-            <a:ext cx="10972800" cy="4572000"/>
+            <a:off x="731520" y="731520"/>
+            <a:ext cx="10058400" cy="914400"/>
           </a:xfrm>
           <a:prstGeom prst="rect">
             <a:avLst/>
@@ -3908,6 +4261,84 @@
           <a:noFill/>
         </p:spPr>
         <p:txBody>
+          <a:bodyPr wrap="none">
+            <a:spAutoFit/>
+          </a:bodyPr>
+          <a:lstStyle/>
+          <a:p>
+            <a:pPr>
+              <a:defRPr b="1" sz="3200">
+                <a:solidFill>
+                  <a:srgbClr val="0F172A"/>
+                </a:solidFill>
+              </a:defRPr>
+            </a:pPr>
+            <a:r>
+              <a:t>3. Зерттеу міндеттері</a:t>
+            </a:r>
+          </a:p>
+        </p:txBody>
+      </p:sp>
+      <p:sp>
+        <p:nvSpPr>
+          <p:cNvPr id="5" name="Rectangle 4"/>
+          <p:cNvSpPr/>
+          <p:nvPr/>
+        </p:nvSpPr>
+        <p:spPr>
+          <a:xfrm>
+            <a:off x="731520" y="1463040"/>
+            <a:ext cx="1371600" cy="36576"/>
+          </a:xfrm>
+          <a:prstGeom prst="rect">
+            <a:avLst/>
+          </a:prstGeom>
+          <a:solidFill>
+            <a:srgbClr val="2563EB"/>
+          </a:solidFill>
+          <a:ln>
+            <a:noFill/>
+          </a:ln>
+        </p:spPr>
+        <p:style>
+          <a:lnRef idx="1">
+            <a:schemeClr val="accent1"/>
+          </a:lnRef>
+          <a:fillRef idx="3">
+            <a:schemeClr val="accent1"/>
+          </a:fillRef>
+          <a:effectRef idx="2">
+            <a:schemeClr val="accent1"/>
+          </a:effectRef>
+          <a:fontRef idx="minor">
+            <a:schemeClr val="lt1"/>
+          </a:fontRef>
+        </p:style>
+        <p:txBody>
+          <a:bodyPr rtlCol="0" anchor="ctr"/>
+          <a:lstStyle/>
+          <a:p>
+            <a:pPr algn="ctr"/>
+          </a:p>
+        </p:txBody>
+      </p:sp>
+      <p:sp>
+        <p:nvSpPr>
+          <p:cNvPr id="6" name="TextBox 5"/>
+          <p:cNvSpPr txBox="1"/>
+          <p:nvPr/>
+        </p:nvSpPr>
+        <p:spPr>
+          <a:xfrm>
+            <a:off x="914400" y="2011680"/>
+            <a:ext cx="10058400" cy="4114800"/>
+          </a:xfrm>
+          <a:prstGeom prst="rect">
+            <a:avLst/>
+          </a:prstGeom>
+          <a:noFill/>
+        </p:spPr>
+        <p:txBody>
           <a:bodyPr wrap="square">
             <a:spAutoFit/>
           </a:bodyPr>
@@ -3916,9 +4347,9 @@
           <a:p>
             <a:pPr>
               <a:spcAft>
-                <a:spcPts val="1200"/>
+                <a:spcPts val="1500"/>
               </a:spcAft>
-              <a:defRPr sz="2000">
+              <a:defRPr sz="2200">
                 <a:solidFill>
                   <a:srgbClr val="334155"/>
                 </a:solidFill>
@@ -3931,9 +4362,9 @@
           <a:p>
             <a:pPr>
               <a:spcAft>
-                <a:spcPts val="1200"/>
+                <a:spcPts val="1500"/>
               </a:spcAft>
-              <a:defRPr sz="2000">
+              <a:defRPr sz="2200">
                 <a:solidFill>
                   <a:srgbClr val="334155"/>
                 </a:solidFill>
@@ -3946,9 +4377,9 @@
           <a:p>
             <a:pPr>
               <a:spcAft>
-                <a:spcPts val="1200"/>
+                <a:spcPts val="1500"/>
               </a:spcAft>
-              <a:defRPr sz="2000">
+              <a:defRPr sz="2200">
                 <a:solidFill>
                   <a:srgbClr val="334155"/>
                 </a:solidFill>
@@ -3961,9 +4392,9 @@
           <a:p>
             <a:pPr>
               <a:spcAft>
-                <a:spcPts val="1200"/>
+                <a:spcPts val="1500"/>
               </a:spcAft>
-              <a:defRPr sz="2000">
+              <a:defRPr sz="2200">
                 <a:solidFill>
                   <a:srgbClr val="334155"/>
                 </a:solidFill>
@@ -3989,7 +4420,7 @@
     <p:bg>
       <p:bgPr>
         <a:solidFill>
-          <a:srgbClr val="FFFFFF"/>
+          <a:srgbClr val="F1F5F9"/>
         </a:solidFill>
         <a:effectLst/>
       </p:bgPr>
@@ -4003,36 +4434,46 @@
       <p:grpSpPr/>
       <p:sp>
         <p:nvSpPr>
-          <p:cNvPr id="2" name="TextBox 1"/>
-          <p:cNvSpPr txBox="1"/>
+          <p:cNvPr id="2" name="Rectangle 1"/>
+          <p:cNvSpPr/>
           <p:nvPr/>
         </p:nvSpPr>
         <p:spPr>
           <a:xfrm>
-            <a:off x="457200" y="457200"/>
-            <a:ext cx="10972800" cy="914400"/>
+            <a:off x="365760" y="365760"/>
+            <a:ext cx="11430000" cy="6126480"/>
           </a:xfrm>
           <a:prstGeom prst="rect">
             <a:avLst/>
           </a:prstGeom>
-          <a:noFill/>
-        </p:spPr>
-        <p:txBody>
-          <a:bodyPr wrap="none">
-            <a:spAutoFit/>
-          </a:bodyPr>
-          <a:lstStyle/>
-          <a:p>
-            <a:pPr>
-              <a:defRPr b="1" sz="3600">
-                <a:solidFill>
-                  <a:srgbClr val="0F172A"/>
-                </a:solidFill>
-              </a:defRPr>
-            </a:pPr>
-            <a:r>
-              <a:t>4. Зерттеу нысаны мен пәні</a:t>
-            </a:r>
+          <a:solidFill>
+            <a:srgbClr val="FFFFFF"/>
+          </a:solidFill>
+          <a:ln w="12700">
+            <a:solidFill>
+              <a:srgbClr val="E2E8F0"/>
+            </a:solidFill>
+          </a:ln>
+        </p:spPr>
+        <p:style>
+          <a:lnRef idx="1">
+            <a:schemeClr val="accent1"/>
+          </a:lnRef>
+          <a:fillRef idx="3">
+            <a:schemeClr val="accent1"/>
+          </a:fillRef>
+          <a:effectRef idx="2">
+            <a:schemeClr val="accent1"/>
+          </a:effectRef>
+          <a:fontRef idx="minor">
+            <a:schemeClr val="lt1"/>
+          </a:fontRef>
+        </p:style>
+        <p:txBody>
+          <a:bodyPr rtlCol="0" anchor="ctr"/>
+          <a:lstStyle/>
+          <a:p>
+            <a:pPr algn="ctr"/>
           </a:p>
         </p:txBody>
       </p:sp>
@@ -4044,8 +4485,8 @@
         </p:nvSpPr>
         <p:spPr>
           <a:xfrm>
-            <a:off x="457200" y="1188720"/>
-            <a:ext cx="1371600" cy="45720"/>
+            <a:off x="365760" y="365760"/>
+            <a:ext cx="11430000" cy="137160"/>
           </a:xfrm>
           <a:prstGeom prst="rect">
             <a:avLst/>
@@ -4087,8 +4528,8 @@
         </p:nvSpPr>
         <p:spPr>
           <a:xfrm>
-            <a:off x="457200" y="1645920"/>
-            <a:ext cx="10972800" cy="4572000"/>
+            <a:off x="731520" y="731520"/>
+            <a:ext cx="10058400" cy="914400"/>
           </a:xfrm>
           <a:prstGeom prst="rect">
             <a:avLst/>
@@ -4096,6 +4537,84 @@
           <a:noFill/>
         </p:spPr>
         <p:txBody>
+          <a:bodyPr wrap="none">
+            <a:spAutoFit/>
+          </a:bodyPr>
+          <a:lstStyle/>
+          <a:p>
+            <a:pPr>
+              <a:defRPr b="1" sz="3200">
+                <a:solidFill>
+                  <a:srgbClr val="0F172A"/>
+                </a:solidFill>
+              </a:defRPr>
+            </a:pPr>
+            <a:r>
+              <a:t>4. Зерттеу нысаны мен пәні</a:t>
+            </a:r>
+          </a:p>
+        </p:txBody>
+      </p:sp>
+      <p:sp>
+        <p:nvSpPr>
+          <p:cNvPr id="5" name="Rectangle 4"/>
+          <p:cNvSpPr/>
+          <p:nvPr/>
+        </p:nvSpPr>
+        <p:spPr>
+          <a:xfrm>
+            <a:off x="731520" y="1463040"/>
+            <a:ext cx="1371600" cy="36576"/>
+          </a:xfrm>
+          <a:prstGeom prst="rect">
+            <a:avLst/>
+          </a:prstGeom>
+          <a:solidFill>
+            <a:srgbClr val="2563EB"/>
+          </a:solidFill>
+          <a:ln>
+            <a:noFill/>
+          </a:ln>
+        </p:spPr>
+        <p:style>
+          <a:lnRef idx="1">
+            <a:schemeClr val="accent1"/>
+          </a:lnRef>
+          <a:fillRef idx="3">
+            <a:schemeClr val="accent1"/>
+          </a:fillRef>
+          <a:effectRef idx="2">
+            <a:schemeClr val="accent1"/>
+          </a:effectRef>
+          <a:fontRef idx="minor">
+            <a:schemeClr val="lt1"/>
+          </a:fontRef>
+        </p:style>
+        <p:txBody>
+          <a:bodyPr rtlCol="0" anchor="ctr"/>
+          <a:lstStyle/>
+          <a:p>
+            <a:pPr algn="ctr"/>
+          </a:p>
+        </p:txBody>
+      </p:sp>
+      <p:sp>
+        <p:nvSpPr>
+          <p:cNvPr id="6" name="TextBox 5"/>
+          <p:cNvSpPr txBox="1"/>
+          <p:nvPr/>
+        </p:nvSpPr>
+        <p:spPr>
+          <a:xfrm>
+            <a:off x="914400" y="2011680"/>
+            <a:ext cx="10058400" cy="4114800"/>
+          </a:xfrm>
+          <a:prstGeom prst="rect">
+            <a:avLst/>
+          </a:prstGeom>
+          <a:noFill/>
+        </p:spPr>
+        <p:txBody>
           <a:bodyPr wrap="square">
             <a:spAutoFit/>
           </a:bodyPr>
@@ -4104,9 +4623,9 @@
           <a:p>
             <a:pPr>
               <a:spcAft>
-                <a:spcPts val="1200"/>
+                <a:spcPts val="1500"/>
               </a:spcAft>
-              <a:defRPr sz="2000">
+              <a:defRPr sz="2200">
                 <a:solidFill>
                   <a:srgbClr val="334155"/>
                 </a:solidFill>
@@ -4119,9 +4638,9 @@
           <a:p>
             <a:pPr>
               <a:spcAft>
-                <a:spcPts val="1200"/>
+                <a:spcPts val="1500"/>
               </a:spcAft>
-              <a:defRPr sz="2000">
+              <a:defRPr sz="2200">
                 <a:solidFill>
                   <a:srgbClr val="334155"/>
                 </a:solidFill>
@@ -4134,9 +4653,9 @@
           <a:p>
             <a:pPr>
               <a:spcAft>
-                <a:spcPts val="1200"/>
+                <a:spcPts val="1500"/>
               </a:spcAft>
-              <a:defRPr sz="2000">
+              <a:defRPr sz="2200">
                 <a:solidFill>
                   <a:srgbClr val="334155"/>
                 </a:solidFill>
@@ -4149,9 +4668,9 @@
           <a:p>
             <a:pPr>
               <a:spcAft>
-                <a:spcPts val="1200"/>
+                <a:spcPts val="1500"/>
               </a:spcAft>
-              <a:defRPr sz="2000">
+              <a:defRPr sz="2200">
                 <a:solidFill>
                   <a:srgbClr val="334155"/>
                 </a:solidFill>
@@ -4177,7 +4696,7 @@
     <p:bg>
       <p:bgPr>
         <a:solidFill>
-          <a:srgbClr val="FFFFFF"/>
+          <a:srgbClr val="F1F5F9"/>
         </a:solidFill>
         <a:effectLst/>
       </p:bgPr>
@@ -4191,36 +4710,46 @@
       <p:grpSpPr/>
       <p:sp>
         <p:nvSpPr>
-          <p:cNvPr id="2" name="TextBox 1"/>
-          <p:cNvSpPr txBox="1"/>
+          <p:cNvPr id="2" name="Rectangle 1"/>
+          <p:cNvSpPr/>
           <p:nvPr/>
         </p:nvSpPr>
         <p:spPr>
           <a:xfrm>
-            <a:off x="457200" y="457200"/>
-            <a:ext cx="10972800" cy="914400"/>
+            <a:off x="365760" y="365760"/>
+            <a:ext cx="11430000" cy="6126480"/>
           </a:xfrm>
           <a:prstGeom prst="rect">
             <a:avLst/>
           </a:prstGeom>
-          <a:noFill/>
-        </p:spPr>
-        <p:txBody>
-          <a:bodyPr wrap="none">
-            <a:spAutoFit/>
-          </a:bodyPr>
-          <a:lstStyle/>
-          <a:p>
-            <a:pPr>
-              <a:defRPr b="1" sz="3600">
-                <a:solidFill>
-                  <a:srgbClr val="0F172A"/>
-                </a:solidFill>
-              </a:defRPr>
-            </a:pPr>
-            <a:r>
-              <a:t>5. Технологиялар Стегі</a:t>
-            </a:r>
+          <a:solidFill>
+            <a:srgbClr val="FFFFFF"/>
+          </a:solidFill>
+          <a:ln w="12700">
+            <a:solidFill>
+              <a:srgbClr val="E2E8F0"/>
+            </a:solidFill>
+          </a:ln>
+        </p:spPr>
+        <p:style>
+          <a:lnRef idx="1">
+            <a:schemeClr val="accent1"/>
+          </a:lnRef>
+          <a:fillRef idx="3">
+            <a:schemeClr val="accent1"/>
+          </a:fillRef>
+          <a:effectRef idx="2">
+            <a:schemeClr val="accent1"/>
+          </a:effectRef>
+          <a:fontRef idx="minor">
+            <a:schemeClr val="lt1"/>
+          </a:fontRef>
+        </p:style>
+        <p:txBody>
+          <a:bodyPr rtlCol="0" anchor="ctr"/>
+          <a:lstStyle/>
+          <a:p>
+            <a:pPr algn="ctr"/>
           </a:p>
         </p:txBody>
       </p:sp>
@@ -4232,8 +4761,8 @@
         </p:nvSpPr>
         <p:spPr>
           <a:xfrm>
-            <a:off x="457200" y="1188720"/>
-            <a:ext cx="1371600" cy="45720"/>
+            <a:off x="365760" y="365760"/>
+            <a:ext cx="11430000" cy="137160"/>
           </a:xfrm>
           <a:prstGeom prst="rect">
             <a:avLst/>
@@ -4275,8 +4804,8 @@
         </p:nvSpPr>
         <p:spPr>
           <a:xfrm>
-            <a:off x="457200" y="1645920"/>
-            <a:ext cx="10972800" cy="4572000"/>
+            <a:off x="731520" y="731520"/>
+            <a:ext cx="10058400" cy="914400"/>
           </a:xfrm>
           <a:prstGeom prst="rect">
             <a:avLst/>
@@ -4284,6 +4813,84 @@
           <a:noFill/>
         </p:spPr>
         <p:txBody>
+          <a:bodyPr wrap="none">
+            <a:spAutoFit/>
+          </a:bodyPr>
+          <a:lstStyle/>
+          <a:p>
+            <a:pPr>
+              <a:defRPr b="1" sz="3200">
+                <a:solidFill>
+                  <a:srgbClr val="0F172A"/>
+                </a:solidFill>
+              </a:defRPr>
+            </a:pPr>
+            <a:r>
+              <a:t>5. Технологиялар Стегі</a:t>
+            </a:r>
+          </a:p>
+        </p:txBody>
+      </p:sp>
+      <p:sp>
+        <p:nvSpPr>
+          <p:cNvPr id="5" name="Rectangle 4"/>
+          <p:cNvSpPr/>
+          <p:nvPr/>
+        </p:nvSpPr>
+        <p:spPr>
+          <a:xfrm>
+            <a:off x="731520" y="1463040"/>
+            <a:ext cx="1371600" cy="36576"/>
+          </a:xfrm>
+          <a:prstGeom prst="rect">
+            <a:avLst/>
+          </a:prstGeom>
+          <a:solidFill>
+            <a:srgbClr val="2563EB"/>
+          </a:solidFill>
+          <a:ln>
+            <a:noFill/>
+          </a:ln>
+        </p:spPr>
+        <p:style>
+          <a:lnRef idx="1">
+            <a:schemeClr val="accent1"/>
+          </a:lnRef>
+          <a:fillRef idx="3">
+            <a:schemeClr val="accent1"/>
+          </a:fillRef>
+          <a:effectRef idx="2">
+            <a:schemeClr val="accent1"/>
+          </a:effectRef>
+          <a:fontRef idx="minor">
+            <a:schemeClr val="lt1"/>
+          </a:fontRef>
+        </p:style>
+        <p:txBody>
+          <a:bodyPr rtlCol="0" anchor="ctr"/>
+          <a:lstStyle/>
+          <a:p>
+            <a:pPr algn="ctr"/>
+          </a:p>
+        </p:txBody>
+      </p:sp>
+      <p:sp>
+        <p:nvSpPr>
+          <p:cNvPr id="6" name="TextBox 5"/>
+          <p:cNvSpPr txBox="1"/>
+          <p:nvPr/>
+        </p:nvSpPr>
+        <p:spPr>
+          <a:xfrm>
+            <a:off x="914400" y="2011680"/>
+            <a:ext cx="10058400" cy="4114800"/>
+          </a:xfrm>
+          <a:prstGeom prst="rect">
+            <a:avLst/>
+          </a:prstGeom>
+          <a:noFill/>
+        </p:spPr>
+        <p:txBody>
           <a:bodyPr wrap="square">
             <a:spAutoFit/>
           </a:bodyPr>
@@ -4292,9 +4899,9 @@
           <a:p>
             <a:pPr>
               <a:spcAft>
-                <a:spcPts val="1200"/>
+                <a:spcPts val="1500"/>
               </a:spcAft>
-              <a:defRPr sz="2000">
+              <a:defRPr sz="2200">
                 <a:solidFill>
                   <a:srgbClr val="334155"/>
                 </a:solidFill>
@@ -4307,9 +4914,9 @@
           <a:p>
             <a:pPr>
               <a:spcAft>
-                <a:spcPts val="1200"/>
+                <a:spcPts val="1500"/>
               </a:spcAft>
-              <a:defRPr sz="2000">
+              <a:defRPr sz="2200">
                 <a:solidFill>
                   <a:srgbClr val="334155"/>
                 </a:solidFill>
@@ -4322,9 +4929,9 @@
           <a:p>
             <a:pPr>
               <a:spcAft>
-                <a:spcPts val="1200"/>
+                <a:spcPts val="1500"/>
               </a:spcAft>
-              <a:defRPr sz="2000">
+              <a:defRPr sz="2200">
                 <a:solidFill>
                   <a:srgbClr val="334155"/>
                 </a:solidFill>
@@ -4337,9 +4944,9 @@
           <a:p>
             <a:pPr>
               <a:spcAft>
-                <a:spcPts val="1200"/>
+                <a:spcPts val="1500"/>
               </a:spcAft>
-              <a:defRPr sz="2000">
+              <a:defRPr sz="2200">
                 <a:solidFill>
                   <a:srgbClr val="334155"/>
                 </a:solidFill>
@@ -4365,7 +4972,7 @@
     <p:bg>
       <p:bgPr>
         <a:solidFill>
-          <a:srgbClr val="FFFFFF"/>
+          <a:srgbClr val="F1F5F9"/>
         </a:solidFill>
         <a:effectLst/>
       </p:bgPr>
@@ -4379,36 +4986,46 @@
       <p:grpSpPr/>
       <p:sp>
         <p:nvSpPr>
-          <p:cNvPr id="2" name="TextBox 1"/>
-          <p:cNvSpPr txBox="1"/>
+          <p:cNvPr id="2" name="Rectangle 1"/>
+          <p:cNvSpPr/>
           <p:nvPr/>
         </p:nvSpPr>
         <p:spPr>
           <a:xfrm>
-            <a:off x="457200" y="457200"/>
-            <a:ext cx="10972800" cy="914400"/>
+            <a:off x="365760" y="365760"/>
+            <a:ext cx="11430000" cy="6126480"/>
           </a:xfrm>
           <a:prstGeom prst="rect">
             <a:avLst/>
           </a:prstGeom>
-          <a:noFill/>
-        </p:spPr>
-        <p:txBody>
-          <a:bodyPr wrap="none">
-            <a:spAutoFit/>
-          </a:bodyPr>
-          <a:lstStyle/>
-          <a:p>
-            <a:pPr>
-              <a:defRPr b="1" sz="3600">
-                <a:solidFill>
-                  <a:srgbClr val="0F172A"/>
-                </a:solidFill>
-              </a:defRPr>
-            </a:pPr>
-            <a:r>
-              <a:t>6. Аналогтарды Талдау</a:t>
-            </a:r>
+          <a:solidFill>
+            <a:srgbClr val="FFFFFF"/>
+          </a:solidFill>
+          <a:ln w="12700">
+            <a:solidFill>
+              <a:srgbClr val="E2E8F0"/>
+            </a:solidFill>
+          </a:ln>
+        </p:spPr>
+        <p:style>
+          <a:lnRef idx="1">
+            <a:schemeClr val="accent1"/>
+          </a:lnRef>
+          <a:fillRef idx="3">
+            <a:schemeClr val="accent1"/>
+          </a:fillRef>
+          <a:effectRef idx="2">
+            <a:schemeClr val="accent1"/>
+          </a:effectRef>
+          <a:fontRef idx="minor">
+            <a:schemeClr val="lt1"/>
+          </a:fontRef>
+        </p:style>
+        <p:txBody>
+          <a:bodyPr rtlCol="0" anchor="ctr"/>
+          <a:lstStyle/>
+          <a:p>
+            <a:pPr algn="ctr"/>
           </a:p>
         </p:txBody>
       </p:sp>
@@ -4420,8 +5037,8 @@
         </p:nvSpPr>
         <p:spPr>
           <a:xfrm>
-            <a:off x="457200" y="1188720"/>
-            <a:ext cx="1371600" cy="45720"/>
+            <a:off x="365760" y="365760"/>
+            <a:ext cx="11430000" cy="137160"/>
           </a:xfrm>
           <a:prstGeom prst="rect">
             <a:avLst/>
@@ -4463,8 +5080,8 @@
         </p:nvSpPr>
         <p:spPr>
           <a:xfrm>
-            <a:off x="457200" y="1645920"/>
-            <a:ext cx="10972800" cy="4572000"/>
+            <a:off x="731520" y="731520"/>
+            <a:ext cx="10058400" cy="914400"/>
           </a:xfrm>
           <a:prstGeom prst="rect">
             <a:avLst/>
@@ -4472,6 +5089,84 @@
           <a:noFill/>
         </p:spPr>
         <p:txBody>
+          <a:bodyPr wrap="none">
+            <a:spAutoFit/>
+          </a:bodyPr>
+          <a:lstStyle/>
+          <a:p>
+            <a:pPr>
+              <a:defRPr b="1" sz="3200">
+                <a:solidFill>
+                  <a:srgbClr val="0F172A"/>
+                </a:solidFill>
+              </a:defRPr>
+            </a:pPr>
+            <a:r>
+              <a:t>6. Аналогтарды Талдау</a:t>
+            </a:r>
+          </a:p>
+        </p:txBody>
+      </p:sp>
+      <p:sp>
+        <p:nvSpPr>
+          <p:cNvPr id="5" name="Rectangle 4"/>
+          <p:cNvSpPr/>
+          <p:nvPr/>
+        </p:nvSpPr>
+        <p:spPr>
+          <a:xfrm>
+            <a:off x="731520" y="1463040"/>
+            <a:ext cx="1371600" cy="36576"/>
+          </a:xfrm>
+          <a:prstGeom prst="rect">
+            <a:avLst/>
+          </a:prstGeom>
+          <a:solidFill>
+            <a:srgbClr val="2563EB"/>
+          </a:solidFill>
+          <a:ln>
+            <a:noFill/>
+          </a:ln>
+        </p:spPr>
+        <p:style>
+          <a:lnRef idx="1">
+            <a:schemeClr val="accent1"/>
+          </a:lnRef>
+          <a:fillRef idx="3">
+            <a:schemeClr val="accent1"/>
+          </a:fillRef>
+          <a:effectRef idx="2">
+            <a:schemeClr val="accent1"/>
+          </a:effectRef>
+          <a:fontRef idx="minor">
+            <a:schemeClr val="lt1"/>
+          </a:fontRef>
+        </p:style>
+        <p:txBody>
+          <a:bodyPr rtlCol="0" anchor="ctr"/>
+          <a:lstStyle/>
+          <a:p>
+            <a:pPr algn="ctr"/>
+          </a:p>
+        </p:txBody>
+      </p:sp>
+      <p:sp>
+        <p:nvSpPr>
+          <p:cNvPr id="6" name="TextBox 5"/>
+          <p:cNvSpPr txBox="1"/>
+          <p:nvPr/>
+        </p:nvSpPr>
+        <p:spPr>
+          <a:xfrm>
+            <a:off x="914400" y="2011680"/>
+            <a:ext cx="10058400" cy="4114800"/>
+          </a:xfrm>
+          <a:prstGeom prst="rect">
+            <a:avLst/>
+          </a:prstGeom>
+          <a:noFill/>
+        </p:spPr>
+        <p:txBody>
           <a:bodyPr wrap="square">
             <a:spAutoFit/>
           </a:bodyPr>
@@ -4480,9 +5175,9 @@
           <a:p>
             <a:pPr>
               <a:spcAft>
-                <a:spcPts val="1200"/>
+                <a:spcPts val="1500"/>
               </a:spcAft>
-              <a:defRPr sz="2000">
+              <a:defRPr sz="2200">
                 <a:solidFill>
                   <a:srgbClr val="334155"/>
                 </a:solidFill>
@@ -4495,9 +5190,9 @@
           <a:p>
             <a:pPr>
               <a:spcAft>
-                <a:spcPts val="1200"/>
+                <a:spcPts val="1500"/>
               </a:spcAft>
-              <a:defRPr sz="2000">
+              <a:defRPr sz="2200">
                 <a:solidFill>
                   <a:srgbClr val="334155"/>
                 </a:solidFill>
@@ -4510,9 +5205,9 @@
           <a:p>
             <a:pPr>
               <a:spcAft>
-                <a:spcPts val="1200"/>
+                <a:spcPts val="1500"/>
               </a:spcAft>
-              <a:defRPr sz="2000">
+              <a:defRPr sz="2200">
                 <a:solidFill>
                   <a:srgbClr val="334155"/>
                 </a:solidFill>
@@ -4525,9 +5220,9 @@
           <a:p>
             <a:pPr>
               <a:spcAft>
-                <a:spcPts val="1200"/>
+                <a:spcPts val="1500"/>
               </a:spcAft>
-              <a:defRPr sz="2000">
+              <a:defRPr sz="2200">
                 <a:solidFill>
                   <a:srgbClr val="334155"/>
                 </a:solidFill>
@@ -4553,7 +5248,7 @@
     <p:bg>
       <p:bgPr>
         <a:solidFill>
-          <a:srgbClr val="FFFFFF"/>
+          <a:srgbClr val="F1F5F9"/>
         </a:solidFill>
         <a:effectLst/>
       </p:bgPr>
@@ -4567,36 +5262,46 @@
       <p:grpSpPr/>
       <p:sp>
         <p:nvSpPr>
-          <p:cNvPr id="2" name="TextBox 1"/>
-          <p:cNvSpPr txBox="1"/>
+          <p:cNvPr id="2" name="Rectangle 1"/>
+          <p:cNvSpPr/>
           <p:nvPr/>
         </p:nvSpPr>
         <p:spPr>
           <a:xfrm>
-            <a:off x="457200" y="457200"/>
-            <a:ext cx="10972800" cy="914400"/>
+            <a:off x="365760" y="365760"/>
+            <a:ext cx="11430000" cy="6126480"/>
           </a:xfrm>
           <a:prstGeom prst="rect">
             <a:avLst/>
           </a:prstGeom>
-          <a:noFill/>
-        </p:spPr>
-        <p:txBody>
-          <a:bodyPr wrap="none">
-            <a:spAutoFit/>
-          </a:bodyPr>
-          <a:lstStyle/>
-          <a:p>
-            <a:pPr>
-              <a:defRPr b="1" sz="3600">
-                <a:solidFill>
-                  <a:srgbClr val="0F172A"/>
-                </a:solidFill>
-              </a:defRPr>
-            </a:pPr>
-            <a:r>
-              <a:t>7. Жүйе Архитектурасы</a:t>
-            </a:r>
+          <a:solidFill>
+            <a:srgbClr val="FFFFFF"/>
+          </a:solidFill>
+          <a:ln w="12700">
+            <a:solidFill>
+              <a:srgbClr val="E2E8F0"/>
+            </a:solidFill>
+          </a:ln>
+        </p:spPr>
+        <p:style>
+          <a:lnRef idx="1">
+            <a:schemeClr val="accent1"/>
+          </a:lnRef>
+          <a:fillRef idx="3">
+            <a:schemeClr val="accent1"/>
+          </a:fillRef>
+          <a:effectRef idx="2">
+            <a:schemeClr val="accent1"/>
+          </a:effectRef>
+          <a:fontRef idx="minor">
+            <a:schemeClr val="lt1"/>
+          </a:fontRef>
+        </p:style>
+        <p:txBody>
+          <a:bodyPr rtlCol="0" anchor="ctr"/>
+          <a:lstStyle/>
+          <a:p>
+            <a:pPr algn="ctr"/>
           </a:p>
         </p:txBody>
       </p:sp>
@@ -4608,8 +5313,8 @@
         </p:nvSpPr>
         <p:spPr>
           <a:xfrm>
-            <a:off x="457200" y="1188720"/>
-            <a:ext cx="1371600" cy="45720"/>
+            <a:off x="365760" y="365760"/>
+            <a:ext cx="11430000" cy="137160"/>
           </a:xfrm>
           <a:prstGeom prst="rect">
             <a:avLst/>
@@ -4651,8 +5356,8 @@
         </p:nvSpPr>
         <p:spPr>
           <a:xfrm>
-            <a:off x="457200" y="1645920"/>
-            <a:ext cx="10972800" cy="4572000"/>
+            <a:off x="731520" y="731520"/>
+            <a:ext cx="10058400" cy="914400"/>
           </a:xfrm>
           <a:prstGeom prst="rect">
             <a:avLst/>
@@ -4660,6 +5365,84 @@
           <a:noFill/>
         </p:spPr>
         <p:txBody>
+          <a:bodyPr wrap="none">
+            <a:spAutoFit/>
+          </a:bodyPr>
+          <a:lstStyle/>
+          <a:p>
+            <a:pPr>
+              <a:defRPr b="1" sz="3200">
+                <a:solidFill>
+                  <a:srgbClr val="0F172A"/>
+                </a:solidFill>
+              </a:defRPr>
+            </a:pPr>
+            <a:r>
+              <a:t>7. Жүйе Архитектурасы</a:t>
+            </a:r>
+          </a:p>
+        </p:txBody>
+      </p:sp>
+      <p:sp>
+        <p:nvSpPr>
+          <p:cNvPr id="5" name="Rectangle 4"/>
+          <p:cNvSpPr/>
+          <p:nvPr/>
+        </p:nvSpPr>
+        <p:spPr>
+          <a:xfrm>
+            <a:off x="731520" y="1463040"/>
+            <a:ext cx="1371600" cy="36576"/>
+          </a:xfrm>
+          <a:prstGeom prst="rect">
+            <a:avLst/>
+          </a:prstGeom>
+          <a:solidFill>
+            <a:srgbClr val="2563EB"/>
+          </a:solidFill>
+          <a:ln>
+            <a:noFill/>
+          </a:ln>
+        </p:spPr>
+        <p:style>
+          <a:lnRef idx="1">
+            <a:schemeClr val="accent1"/>
+          </a:lnRef>
+          <a:fillRef idx="3">
+            <a:schemeClr val="accent1"/>
+          </a:fillRef>
+          <a:effectRef idx="2">
+            <a:schemeClr val="accent1"/>
+          </a:effectRef>
+          <a:fontRef idx="minor">
+            <a:schemeClr val="lt1"/>
+          </a:fontRef>
+        </p:style>
+        <p:txBody>
+          <a:bodyPr rtlCol="0" anchor="ctr"/>
+          <a:lstStyle/>
+          <a:p>
+            <a:pPr algn="ctr"/>
+          </a:p>
+        </p:txBody>
+      </p:sp>
+      <p:sp>
+        <p:nvSpPr>
+          <p:cNvPr id="6" name="TextBox 5"/>
+          <p:cNvSpPr txBox="1"/>
+          <p:nvPr/>
+        </p:nvSpPr>
+        <p:spPr>
+          <a:xfrm>
+            <a:off x="914400" y="2011680"/>
+            <a:ext cx="10058400" cy="4114800"/>
+          </a:xfrm>
+          <a:prstGeom prst="rect">
+            <a:avLst/>
+          </a:prstGeom>
+          <a:noFill/>
+        </p:spPr>
+        <p:txBody>
           <a:bodyPr wrap="square">
             <a:spAutoFit/>
           </a:bodyPr>
@@ -4668,9 +5451,9 @@
           <a:p>
             <a:pPr>
               <a:spcAft>
-                <a:spcPts val="1200"/>
+                <a:spcPts val="1500"/>
               </a:spcAft>
-              <a:defRPr sz="2000">
+              <a:defRPr sz="2200">
                 <a:solidFill>
                   <a:srgbClr val="334155"/>
                 </a:solidFill>
@@ -4683,9 +5466,9 @@
           <a:p>
             <a:pPr>
               <a:spcAft>
-                <a:spcPts val="1200"/>
+                <a:spcPts val="1500"/>
               </a:spcAft>
-              <a:defRPr sz="2000">
+              <a:defRPr sz="2200">
                 <a:solidFill>
                   <a:srgbClr val="334155"/>
                 </a:solidFill>
@@ -4698,9 +5481,9 @@
           <a:p>
             <a:pPr>
               <a:spcAft>
-                <a:spcPts val="1200"/>
+                <a:spcPts val="1500"/>
               </a:spcAft>
-              <a:defRPr sz="2000">
+              <a:defRPr sz="2200">
                 <a:solidFill>
                   <a:srgbClr val="334155"/>
                 </a:solidFill>
@@ -4713,9 +5496,9 @@
           <a:p>
             <a:pPr>
               <a:spcAft>
-                <a:spcPts val="1200"/>
+                <a:spcPts val="1500"/>
               </a:spcAft>
-              <a:defRPr sz="2000">
+              <a:defRPr sz="2200">
                 <a:solidFill>
                   <a:srgbClr val="334155"/>
                 </a:solidFill>
@@ -4741,7 +5524,7 @@
     <p:bg>
       <p:bgPr>
         <a:solidFill>
-          <a:srgbClr val="FFFFFF"/>
+          <a:srgbClr val="F1F5F9"/>
         </a:solidFill>
         <a:effectLst/>
       </p:bgPr>
@@ -4755,36 +5538,46 @@
       <p:grpSpPr/>
       <p:sp>
         <p:nvSpPr>
-          <p:cNvPr id="2" name="TextBox 1"/>
-          <p:cNvSpPr txBox="1"/>
+          <p:cNvPr id="2" name="Rectangle 1"/>
+          <p:cNvSpPr/>
           <p:nvPr/>
         </p:nvSpPr>
         <p:spPr>
           <a:xfrm>
-            <a:off x="457200" y="457200"/>
-            <a:ext cx="10972800" cy="914400"/>
+            <a:off x="365760" y="365760"/>
+            <a:ext cx="11430000" cy="6126480"/>
           </a:xfrm>
           <a:prstGeom prst="rect">
             <a:avLst/>
           </a:prstGeom>
-          <a:noFill/>
-        </p:spPr>
-        <p:txBody>
-          <a:bodyPr wrap="none">
-            <a:spAutoFit/>
-          </a:bodyPr>
-          <a:lstStyle/>
-          <a:p>
-            <a:pPr>
-              <a:defRPr b="1" sz="3600">
-                <a:solidFill>
-                  <a:srgbClr val="0F172A"/>
-                </a:solidFill>
-              </a:defRPr>
-            </a:pPr>
-            <a:r>
-              <a:t>8. Машиналық Оқыту: LSTM</a:t>
-            </a:r>
+          <a:solidFill>
+            <a:srgbClr val="FFFFFF"/>
+          </a:solidFill>
+          <a:ln w="12700">
+            <a:solidFill>
+              <a:srgbClr val="E2E8F0"/>
+            </a:solidFill>
+          </a:ln>
+        </p:spPr>
+        <p:style>
+          <a:lnRef idx="1">
+            <a:schemeClr val="accent1"/>
+          </a:lnRef>
+          <a:fillRef idx="3">
+            <a:schemeClr val="accent1"/>
+          </a:fillRef>
+          <a:effectRef idx="2">
+            <a:schemeClr val="accent1"/>
+          </a:effectRef>
+          <a:fontRef idx="minor">
+            <a:schemeClr val="lt1"/>
+          </a:fontRef>
+        </p:style>
+        <p:txBody>
+          <a:bodyPr rtlCol="0" anchor="ctr"/>
+          <a:lstStyle/>
+          <a:p>
+            <a:pPr algn="ctr"/>
           </a:p>
         </p:txBody>
       </p:sp>
@@ -4796,8 +5589,8 @@
         </p:nvSpPr>
         <p:spPr>
           <a:xfrm>
-            <a:off x="457200" y="1188720"/>
-            <a:ext cx="1371600" cy="45720"/>
+            <a:off x="365760" y="365760"/>
+            <a:ext cx="11430000" cy="137160"/>
           </a:xfrm>
           <a:prstGeom prst="rect">
             <a:avLst/>
@@ -4839,8 +5632,8 @@
         </p:nvSpPr>
         <p:spPr>
           <a:xfrm>
-            <a:off x="457200" y="1645920"/>
-            <a:ext cx="10972800" cy="4572000"/>
+            <a:off x="731520" y="731520"/>
+            <a:ext cx="10058400" cy="914400"/>
           </a:xfrm>
           <a:prstGeom prst="rect">
             <a:avLst/>
@@ -4848,6 +5641,84 @@
           <a:noFill/>
         </p:spPr>
         <p:txBody>
+          <a:bodyPr wrap="none">
+            <a:spAutoFit/>
+          </a:bodyPr>
+          <a:lstStyle/>
+          <a:p>
+            <a:pPr>
+              <a:defRPr b="1" sz="3200">
+                <a:solidFill>
+                  <a:srgbClr val="0F172A"/>
+                </a:solidFill>
+              </a:defRPr>
+            </a:pPr>
+            <a:r>
+              <a:t>8. Машиналық Оқыту: LSTM</a:t>
+            </a:r>
+          </a:p>
+        </p:txBody>
+      </p:sp>
+      <p:sp>
+        <p:nvSpPr>
+          <p:cNvPr id="5" name="Rectangle 4"/>
+          <p:cNvSpPr/>
+          <p:nvPr/>
+        </p:nvSpPr>
+        <p:spPr>
+          <a:xfrm>
+            <a:off x="731520" y="1463040"/>
+            <a:ext cx="1371600" cy="36576"/>
+          </a:xfrm>
+          <a:prstGeom prst="rect">
+            <a:avLst/>
+          </a:prstGeom>
+          <a:solidFill>
+            <a:srgbClr val="2563EB"/>
+          </a:solidFill>
+          <a:ln>
+            <a:noFill/>
+          </a:ln>
+        </p:spPr>
+        <p:style>
+          <a:lnRef idx="1">
+            <a:schemeClr val="accent1"/>
+          </a:lnRef>
+          <a:fillRef idx="3">
+            <a:schemeClr val="accent1"/>
+          </a:fillRef>
+          <a:effectRef idx="2">
+            <a:schemeClr val="accent1"/>
+          </a:effectRef>
+          <a:fontRef idx="minor">
+            <a:schemeClr val="lt1"/>
+          </a:fontRef>
+        </p:style>
+        <p:txBody>
+          <a:bodyPr rtlCol="0" anchor="ctr"/>
+          <a:lstStyle/>
+          <a:p>
+            <a:pPr algn="ctr"/>
+          </a:p>
+        </p:txBody>
+      </p:sp>
+      <p:sp>
+        <p:nvSpPr>
+          <p:cNvPr id="6" name="TextBox 5"/>
+          <p:cNvSpPr txBox="1"/>
+          <p:nvPr/>
+        </p:nvSpPr>
+        <p:spPr>
+          <a:xfrm>
+            <a:off x="914400" y="2011680"/>
+            <a:ext cx="10058400" cy="4114800"/>
+          </a:xfrm>
+          <a:prstGeom prst="rect">
+            <a:avLst/>
+          </a:prstGeom>
+          <a:noFill/>
+        </p:spPr>
+        <p:txBody>
           <a:bodyPr wrap="square">
             <a:spAutoFit/>
           </a:bodyPr>
@@ -4856,9 +5727,9 @@
           <a:p>
             <a:pPr>
               <a:spcAft>
-                <a:spcPts val="1200"/>
+                <a:spcPts val="1500"/>
               </a:spcAft>
-              <a:defRPr sz="2000">
+              <a:defRPr sz="2200">
                 <a:solidFill>
                   <a:srgbClr val="334155"/>
                 </a:solidFill>
@@ -4871,9 +5742,9 @@
           <a:p>
             <a:pPr>
               <a:spcAft>
-                <a:spcPts val="1200"/>
+                <a:spcPts val="1500"/>
               </a:spcAft>
-              <a:defRPr sz="2000">
+              <a:defRPr sz="2200">
                 <a:solidFill>
                   <a:srgbClr val="334155"/>
                 </a:solidFill>
@@ -4886,9 +5757,9 @@
           <a:p>
             <a:pPr>
               <a:spcAft>
-                <a:spcPts val="1200"/>
+                <a:spcPts val="1500"/>
               </a:spcAft>
-              <a:defRPr sz="2000">
+              <a:defRPr sz="2200">
                 <a:solidFill>
                   <a:srgbClr val="334155"/>
                 </a:solidFill>
@@ -4901,9 +5772,9 @@
           <a:p>
             <a:pPr>
               <a:spcAft>
-                <a:spcPts val="1200"/>
+                <a:spcPts val="1500"/>
               </a:spcAft>
-              <a:defRPr sz="2000">
+              <a:defRPr sz="2200">
                 <a:solidFill>
                   <a:srgbClr val="334155"/>
                 </a:solidFill>

</xml_diff>